<commit_message>
Add presentation slides for metadata modeling (slot 6)
</commit_message>
<xml_diff>
--- a/docs/slides/fairst-workflow-slides-editable.pptx
+++ b/docs/slides/fairst-workflow-slides-editable.pptx
@@ -6,14 +6,11 @@
   </p:sldMasterIdLst>
   <p:sldIdLst>
     <p:sldId id="256" r:id="rId7"/>
-    <p:sldId id="257" r:id="rId8"/>
-    <p:sldId id="258" r:id="rId9"/>
-    <p:sldId id="259" r:id="rId10"/>
-    <p:sldId id="260" r:id="rId11"/>
-    <p:sldId id="261" r:id="rId12"/>
-    <p:sldId id="262" r:id="rId13"/>
-    <p:sldId id="263" r:id="rId14"/>
-    <p:sldId id="264" r:id="rId15"/>
+    <p:sldId id="257" r:id="rId9"/>
+    <p:sldId id="258" r:id="rId10"/>
+    <p:sldId id="259" r:id="rId11"/>
+    <p:sldId id="260" r:id="rId12"/>
+    <p:sldId id="261" r:id="rId13"/>
   </p:sldIdLst>
   <p:sldSz cx="12191695" cy="6858000" type="screen4x3"/>
   <p:notesSz cx="6858000" cy="9144000"/>
@@ -113,6 +110,925 @@
     </a:lvl9pPr>
   </p:defaultTextStyle>
 </p:presentation>
+</file>
+
+<file path=ppt/notesMasters/notesMaster1.xml><?xml version="1.0" encoding="utf-8"?>
+<p:notesMaster xmlns:a="http://schemas.openxmlformats.org/drawingml/2006/main" xmlns:p="http://schemas.openxmlformats.org/presentationml/2006/main" xmlns:r="http://schemas.openxmlformats.org/officeDocument/2006/relationships">
+  <p:cSld>
+    <p:bg>
+      <p:bgRef idx="1001">
+        <a:schemeClr val="bg1"/>
+      </p:bgRef>
+    </p:bg>
+    <p:spTree>
+      <p:nvGrpSpPr>
+        <p:cNvPr id="1" name=""/>
+        <p:cNvGrpSpPr/>
+        <p:nvPr/>
+      </p:nvGrpSpPr>
+      <p:grpSpPr>
+        <a:xfrm>
+          <a:off x="0" y="0"/>
+          <a:ext cx="0" cy="0"/>
+          <a:chOff x="0" y="0"/>
+          <a:chExt cx="0" cy="0"/>
+        </a:xfrm>
+      </p:grpSpPr>
+      <p:sp>
+        <p:nvSpPr>
+          <p:cNvPr id="2" name="Header Placeholder 1"/>
+          <p:cNvSpPr>
+            <a:spLocks noGrp="1"/>
+          </p:cNvSpPr>
+          <p:nvPr>
+            <p:ph type="hdr" sz="quarter"/>
+          </p:nvPr>
+        </p:nvSpPr>
+        <p:spPr>
+          <a:xfrm>
+            <a:off x="0" y="0"/>
+            <a:ext cx="2971800" cy="457200"/>
+          </a:xfrm>
+          <a:prstGeom prst="rect">
+            <a:avLst/>
+          </a:prstGeom>
+        </p:spPr>
+        <p:txBody>
+          <a:bodyPr vert="horz" lIns="91440" tIns="45720" rIns="91440" bIns="45720" rtlCol="0"/>
+          <a:lstStyle>
+            <a:lvl1pPr algn="l">
+              <a:defRPr sz="1200"/>
+            </a:lvl1pPr>
+          </a:lstStyle>
+          <a:p>
+            <a:endParaRPr lang="en-US"/>
+          </a:p>
+        </p:txBody>
+      </p:sp>
+      <p:sp>
+        <p:nvSpPr>
+          <p:cNvPr id="3" name="Date Placeholder 2"/>
+          <p:cNvSpPr>
+            <a:spLocks noGrp="1"/>
+          </p:cNvSpPr>
+          <p:nvPr>
+            <p:ph type="dt" idx="1"/>
+          </p:nvPr>
+        </p:nvSpPr>
+        <p:spPr>
+          <a:xfrm>
+            <a:off x="3884613" y="0"/>
+            <a:ext cx="2971800" cy="457200"/>
+          </a:xfrm>
+          <a:prstGeom prst="rect">
+            <a:avLst/>
+          </a:prstGeom>
+        </p:spPr>
+        <p:txBody>
+          <a:bodyPr vert="horz" lIns="91440" tIns="45720" rIns="91440" bIns="45720" rtlCol="0"/>
+          <a:lstStyle>
+            <a:lvl1pPr algn="r">
+              <a:defRPr sz="1200"/>
+            </a:lvl1pPr>
+          </a:lstStyle>
+          <a:p>
+            <a:fld id="{0F89C1C7-3DCD-1040-A9CF-14679D8B5DDD}" type="datetimeFigureOut">
+              <a:rPr lang="en-US" smtClean="0"/>
+              <a:t>10/17/16</a:t>
+            </a:fld>
+            <a:endParaRPr lang="en-US"/>
+          </a:p>
+        </p:txBody>
+      </p:sp>
+      <p:sp>
+        <p:nvSpPr>
+          <p:cNvPr id="4" name="Slide Image Placeholder 3"/>
+          <p:cNvSpPr>
+            <a:spLocks noGrp="1" noRot="1" noChangeAspect="1"/>
+          </p:cNvSpPr>
+          <p:nvPr>
+            <p:ph type="sldImg" idx="2"/>
+          </p:nvPr>
+        </p:nvSpPr>
+        <p:spPr>
+          <a:xfrm>
+            <a:off x="1143000" y="685800"/>
+            <a:ext cx="4572000" cy="3429000"/>
+          </a:xfrm>
+          <a:prstGeom prst="rect">
+            <a:avLst/>
+          </a:prstGeom>
+          <a:noFill/>
+          <a:ln w="12700">
+            <a:solidFill>
+              <a:prstClr val="black"/>
+            </a:solidFill>
+          </a:ln>
+        </p:spPr>
+        <p:txBody>
+          <a:bodyPr vert="horz" lIns="91440" tIns="45720" rIns="91440" bIns="45720" rtlCol="0" anchor="ctr"/>
+          <a:lstStyle/>
+          <a:p>
+            <a:endParaRPr lang="en-US"/>
+          </a:p>
+        </p:txBody>
+      </p:sp>
+      <p:sp>
+        <p:nvSpPr>
+          <p:cNvPr id="5" name="Notes Placeholder 4"/>
+          <p:cNvSpPr>
+            <a:spLocks noGrp="1"/>
+          </p:cNvSpPr>
+          <p:nvPr>
+            <p:ph type="body" sz="quarter" idx="3"/>
+          </p:nvPr>
+        </p:nvSpPr>
+        <p:spPr>
+          <a:xfrm>
+            <a:off x="685800" y="4343400"/>
+            <a:ext cx="5486400" cy="4114800"/>
+          </a:xfrm>
+          <a:prstGeom prst="rect">
+            <a:avLst/>
+          </a:prstGeom>
+        </p:spPr>
+        <p:txBody>
+          <a:bodyPr vert="horz" lIns="91440" tIns="45720" rIns="91440" bIns="45720" rtlCol="0"/>
+          <a:lstStyle/>
+          <a:p>
+            <a:pPr lvl="0"/>
+            <a:r>
+              <a:rPr lang="en-US" smtClean="0"/>
+              <a:t>Click to edit Master text styles</a:t>
+            </a:r>
+          </a:p>
+          <a:p>
+            <a:pPr lvl="1"/>
+            <a:r>
+              <a:rPr lang="en-US" smtClean="0"/>
+              <a:t>Second level</a:t>
+            </a:r>
+          </a:p>
+          <a:p>
+            <a:pPr lvl="2"/>
+            <a:r>
+              <a:rPr lang="en-US" smtClean="0"/>
+              <a:t>Third level</a:t>
+            </a:r>
+          </a:p>
+          <a:p>
+            <a:pPr lvl="3"/>
+            <a:r>
+              <a:rPr lang="en-US" smtClean="0"/>
+              <a:t>Fourth level</a:t>
+            </a:r>
+          </a:p>
+          <a:p>
+            <a:pPr lvl="4"/>
+            <a:r>
+              <a:rPr lang="en-US" smtClean="0"/>
+              <a:t>Fifth level</a:t>
+            </a:r>
+            <a:endParaRPr lang="en-US"/>
+          </a:p>
+        </p:txBody>
+      </p:sp>
+      <p:sp>
+        <p:nvSpPr>
+          <p:cNvPr id="6" name="Footer Placeholder 5"/>
+          <p:cNvSpPr>
+            <a:spLocks noGrp="1"/>
+          </p:cNvSpPr>
+          <p:nvPr>
+            <p:ph type="ftr" sz="quarter" idx="4"/>
+          </p:nvPr>
+        </p:nvSpPr>
+        <p:spPr>
+          <a:xfrm>
+            <a:off x="0" y="8685213"/>
+            <a:ext cx="2971800" cy="457200"/>
+          </a:xfrm>
+          <a:prstGeom prst="rect">
+            <a:avLst/>
+          </a:prstGeom>
+        </p:spPr>
+        <p:txBody>
+          <a:bodyPr vert="horz" lIns="91440" tIns="45720" rIns="91440" bIns="45720" rtlCol="0" anchor="b"/>
+          <a:lstStyle>
+            <a:lvl1pPr algn="l">
+              <a:defRPr sz="1200"/>
+            </a:lvl1pPr>
+          </a:lstStyle>
+          <a:p>
+            <a:endParaRPr lang="en-US"/>
+          </a:p>
+        </p:txBody>
+      </p:sp>
+      <p:sp>
+        <p:nvSpPr>
+          <p:cNvPr id="7" name="Slide Number Placeholder 6"/>
+          <p:cNvSpPr>
+            <a:spLocks noGrp="1"/>
+          </p:cNvSpPr>
+          <p:nvPr>
+            <p:ph type="sldNum" sz="quarter" idx="5"/>
+          </p:nvPr>
+        </p:nvSpPr>
+        <p:spPr>
+          <a:xfrm>
+            <a:off x="3884613" y="8685213"/>
+            <a:ext cx="2971800" cy="457200"/>
+          </a:xfrm>
+          <a:prstGeom prst="rect">
+            <a:avLst/>
+          </a:prstGeom>
+        </p:spPr>
+        <p:txBody>
+          <a:bodyPr vert="horz" lIns="91440" tIns="45720" rIns="91440" bIns="45720" rtlCol="0" anchor="b"/>
+          <a:lstStyle>
+            <a:lvl1pPr algn="r">
+              <a:defRPr sz="1200"/>
+            </a:lvl1pPr>
+          </a:lstStyle>
+          <a:p>
+            <a:fld id="{BB5E49A5-4136-284D-997B-48E1D791AD67}" type="slidenum">
+              <a:rPr lang="en-US" smtClean="0"/>
+              <a:t>‹#›</a:t>
+            </a:fld>
+            <a:endParaRPr lang="en-US"/>
+          </a:p>
+        </p:txBody>
+      </p:sp>
+    </p:spTree>
+    <p:extLst>
+      <p:ext uri="{BB962C8B-B14F-4D97-AF65-F5344CB8AC3E}">
+        <p14:creationId xmlns:p14="http://schemas.microsoft.com/office/powerpoint/2010/main" val="2623252185"/>
+      </p:ext>
+    </p:extLst>
+  </p:cSld>
+  <p:clrMap bg1="lt1" tx1="dk1" bg2="lt2" tx2="dk2" accent1="accent1" accent2="accent2" accent3="accent3" accent4="accent4" accent5="accent5" accent6="accent6" hlink="hlink" folHlink="folHlink"/>
+  <p:notesStyle>
+    <a:lvl1pPr marL="0" algn="l" defTabSz="457200" rtl="0" eaLnBrk="1" latinLnBrk="0" hangingPunct="1">
+      <a:defRPr sz="1200" kern="1200">
+        <a:solidFill>
+          <a:schemeClr val="tx1"/>
+        </a:solidFill>
+        <a:latin typeface="+mn-lt"/>
+        <a:ea typeface="+mn-ea"/>
+        <a:cs typeface="+mn-cs"/>
+      </a:defRPr>
+    </a:lvl1pPr>
+    <a:lvl2pPr marL="457200" algn="l" defTabSz="457200" rtl="0" eaLnBrk="1" latinLnBrk="0" hangingPunct="1">
+      <a:defRPr sz="1200" kern="1200">
+        <a:solidFill>
+          <a:schemeClr val="tx1"/>
+        </a:solidFill>
+        <a:latin typeface="+mn-lt"/>
+        <a:ea typeface="+mn-ea"/>
+        <a:cs typeface="+mn-cs"/>
+      </a:defRPr>
+    </a:lvl2pPr>
+    <a:lvl3pPr marL="914400" algn="l" defTabSz="457200" rtl="0" eaLnBrk="1" latinLnBrk="0" hangingPunct="1">
+      <a:defRPr sz="1200" kern="1200">
+        <a:solidFill>
+          <a:schemeClr val="tx1"/>
+        </a:solidFill>
+        <a:latin typeface="+mn-lt"/>
+        <a:ea typeface="+mn-ea"/>
+        <a:cs typeface="+mn-cs"/>
+      </a:defRPr>
+    </a:lvl3pPr>
+    <a:lvl4pPr marL="1371600" algn="l" defTabSz="457200" rtl="0" eaLnBrk="1" latinLnBrk="0" hangingPunct="1">
+      <a:defRPr sz="1200" kern="1200">
+        <a:solidFill>
+          <a:schemeClr val="tx1"/>
+        </a:solidFill>
+        <a:latin typeface="+mn-lt"/>
+        <a:ea typeface="+mn-ea"/>
+        <a:cs typeface="+mn-cs"/>
+      </a:defRPr>
+    </a:lvl4pPr>
+    <a:lvl5pPr marL="1828800" algn="l" defTabSz="457200" rtl="0" eaLnBrk="1" latinLnBrk="0" hangingPunct="1">
+      <a:defRPr sz="1200" kern="1200">
+        <a:solidFill>
+          <a:schemeClr val="tx1"/>
+        </a:solidFill>
+        <a:latin typeface="+mn-lt"/>
+        <a:ea typeface="+mn-ea"/>
+        <a:cs typeface="+mn-cs"/>
+      </a:defRPr>
+    </a:lvl5pPr>
+    <a:lvl6pPr marL="2286000" algn="l" defTabSz="457200" rtl="0" eaLnBrk="1" latinLnBrk="0" hangingPunct="1">
+      <a:defRPr sz="1200" kern="1200">
+        <a:solidFill>
+          <a:schemeClr val="tx1"/>
+        </a:solidFill>
+        <a:latin typeface="+mn-lt"/>
+        <a:ea typeface="+mn-ea"/>
+        <a:cs typeface="+mn-cs"/>
+      </a:defRPr>
+    </a:lvl6pPr>
+    <a:lvl7pPr marL="2743200" algn="l" defTabSz="457200" rtl="0" eaLnBrk="1" latinLnBrk="0" hangingPunct="1">
+      <a:defRPr sz="1200" kern="1200">
+        <a:solidFill>
+          <a:schemeClr val="tx1"/>
+        </a:solidFill>
+        <a:latin typeface="+mn-lt"/>
+        <a:ea typeface="+mn-ea"/>
+        <a:cs typeface="+mn-cs"/>
+      </a:defRPr>
+    </a:lvl7pPr>
+    <a:lvl8pPr marL="3200400" algn="l" defTabSz="457200" rtl="0" eaLnBrk="1" latinLnBrk="0" hangingPunct="1">
+      <a:defRPr sz="1200" kern="1200">
+        <a:solidFill>
+          <a:schemeClr val="tx1"/>
+        </a:solidFill>
+        <a:latin typeface="+mn-lt"/>
+        <a:ea typeface="+mn-ea"/>
+        <a:cs typeface="+mn-cs"/>
+      </a:defRPr>
+    </a:lvl8pPr>
+    <a:lvl9pPr marL="3657600" algn="l" defTabSz="457200" rtl="0" eaLnBrk="1" latinLnBrk="0" hangingPunct="1">
+      <a:defRPr sz="1200" kern="1200">
+        <a:solidFill>
+          <a:schemeClr val="tx1"/>
+        </a:solidFill>
+        <a:latin typeface="+mn-lt"/>
+        <a:ea typeface="+mn-ea"/>
+        <a:cs typeface="+mn-cs"/>
+      </a:defRPr>
+    </a:lvl9pPr>
+  </p:notesStyle>
+</p:notesMaster>
+</file>
+
+<file path=ppt/notesSlides/notesSlide1.xml><?xml version="1.0" encoding="utf-8"?>
+<p:notes xmlns:a="http://schemas.openxmlformats.org/drawingml/2006/main" xmlns:p="http://schemas.openxmlformats.org/presentationml/2006/main" xmlns:r="http://schemas.openxmlformats.org/officeDocument/2006/relationships">
+  <p:cSld>
+    <p:spTree>
+      <p:nvGrpSpPr>
+        <p:cNvPr id="1" name=""/>
+        <p:cNvGrpSpPr/>
+        <p:nvPr/>
+      </p:nvGrpSpPr>
+      <p:grpSpPr>
+        <a:xfrm>
+          <a:off x="0" y="0"/>
+          <a:ext cx="0" cy="0"/>
+          <a:chOff x="0" y="0"/>
+          <a:chExt cx="0" cy="0"/>
+        </a:xfrm>
+      </p:grpSpPr>
+      <p:sp>
+        <p:nvSpPr>
+          <p:cNvPr id="2" name="Slide Image Placeholder 1"/>
+          <p:cNvSpPr>
+            <a:spLocks noGrp="1"/>
+          </p:cNvSpPr>
+          <p:nvPr>
+            <p:ph type="sldImg" idx="2"/>
+          </p:nvPr>
+        </p:nvSpPr>
+        <p:spPr/>
+      </p:sp>
+      <p:sp>
+        <p:nvSpPr>
+          <p:cNvPr id="3" name="Notes Placeholder 2"/>
+          <p:cNvSpPr>
+            <a:spLocks noGrp="1"/>
+          </p:cNvSpPr>
+          <p:nvPr>
+            <p:ph type="body" idx="3" sz="quarter"/>
+          </p:nvPr>
+        </p:nvSpPr>
+        <p:spPr/>
+        <p:txBody>
+          <a:bodyPr/>
+          <a:lstStyle/>
+          <a:p>
+            <a:r>
+              <a:t>Agricultural research data lives across dozens of repositories with different schemas, formats, and conventions. ARCs (Annotated Research Contexts) are the emerging standard for packaging that data, and FAIRagro's Search Hub is where researchers discover it. FAIRweaver's conversion pipeline bridges the gap: take metadata from any source, map it into an ARC, then extract the FAIRagro-specific schema for Search Hub ingestion.</a:t>
+            </a:r>
+          </a:p>
+          <a:p/>
+          <a:p>
+            <a:r>
+              <a:t>The challenge is structural. Every ARC is a JSON-LD graph, and different research groups model the same domain concepts at different depths and in different graph locations. The pipeline must handle that variability — or define conventions to eliminate it.</a:t>
+            </a:r>
+          </a:p>
+        </p:txBody>
+      </p:sp>
+      <p:sp>
+        <p:nvSpPr>
+          <p:cNvPr id="4" name="Slide Number Placeholder 3"/>
+          <p:cNvSpPr>
+            <a:spLocks noGrp="1"/>
+          </p:cNvSpPr>
+          <p:nvPr>
+            <p:ph type="sldNum" idx="5" sz="quarter"/>
+          </p:nvPr>
+        </p:nvSpPr>
+        <p:spPr/>
+      </p:sp>
+    </p:spTree>
+  </p:cSld>
+  <p:clrMapOvr>
+    <a:masterClrMapping/>
+  </p:clrMapOvr>
+</p:notes>
+</file>
+
+<file path=ppt/notesSlides/notesSlide2.xml><?xml version="1.0" encoding="utf-8"?>
+<p:notes xmlns:a="http://schemas.openxmlformats.org/drawingml/2006/main" xmlns:p="http://schemas.openxmlformats.org/presentationml/2006/main" xmlns:r="http://schemas.openxmlformats.org/officeDocument/2006/relationships">
+  <p:cSld>
+    <p:spTree>
+      <p:nvGrpSpPr>
+        <p:cNvPr id="1" name=""/>
+        <p:cNvGrpSpPr/>
+        <p:nvPr/>
+      </p:nvGrpSpPr>
+      <p:grpSpPr>
+        <a:xfrm>
+          <a:off x="0" y="0"/>
+          <a:ext cx="0" cy="0"/>
+          <a:chOff x="0" y="0"/>
+          <a:chExt cx="0" cy="0"/>
+        </a:xfrm>
+      </p:grpSpPr>
+      <p:sp>
+        <p:nvSpPr>
+          <p:cNvPr id="2" name="Slide Image Placeholder 1"/>
+          <p:cNvSpPr>
+            <a:spLocks noGrp="1"/>
+          </p:cNvSpPr>
+          <p:nvPr>
+            <p:ph type="sldImg" idx="2"/>
+          </p:nvPr>
+        </p:nvSpPr>
+        <p:spPr/>
+      </p:sp>
+      <p:sp>
+        <p:nvSpPr>
+          <p:cNvPr id="3" name="Notes Placeholder 2"/>
+          <p:cNvSpPr>
+            <a:spLocks noGrp="1"/>
+          </p:cNvSpPr>
+          <p:nvPr>
+            <p:ph type="body" idx="3" sz="quarter"/>
+          </p:nvPr>
+        </p:nvSpPr>
+        <p:spPr/>
+        <p:txBody>
+          <a:bodyPr/>
+          <a:lstStyle/>
+          <a:p>
+            <a:r>
+              <a:t>The pipeline is strictly sequential. Schema.org JSON-LD from an RDI (Research Data Infrastructure) enters at the top, gets transformed by FAIRagro templates, and produces two outputs in order:</a:t>
+            </a:r>
+          </a:p>
+          <a:p/>
+          <a:p>
+            <a:r>
+              <a:t>1. Output A — ARC RO-Crate. A JSON-LD document that follows the ARC specification.</a:t>
+            </a:r>
+          </a:p>
+          <a:p>
+            <a:r>
+              <a:t>2. Output B — FAIRagro JSON. Derived from Output A, not produced independently.</a:t>
+            </a:r>
+          </a:p>
+          <a:p/>
+          <a:p>
+            <a:r>
+              <a:t>Output B's dependency on Output A is the key architectural insight. If the ARC is incomplete, the FAIRagro extraction is incomplete too. There is no shortcut.</a:t>
+            </a:r>
+          </a:p>
+          <a:p/>
+          <a:p>
+            <a:r>
+              <a:t>Two paths feed the ARC into Search Hub:</a:t>
+            </a:r>
+          </a:p>
+          <a:p>
+            <a:r>
+              <a:t>- Path 1 (direct harvest): GitLab DataHub stores the ARC; a harvester reads it and produces FAIRagro JSON.</a:t>
+            </a:r>
+          </a:p>
+          <a:p>
+            <a:r>
+              <a:t>- Path 2 (orchestrated): The FAIRagro Middleware API coordinates the full workflow, from harvest through conversion to ingestion.</a:t>
+            </a:r>
+          </a:p>
+          <a:p/>
+          <a:p>
+            <a:r>
+              <a:t>Both paths converge on the same FAIRagro schema.json consumed by Search Hub.</a:t>
+            </a:r>
+          </a:p>
+        </p:txBody>
+      </p:sp>
+      <p:sp>
+        <p:nvSpPr>
+          <p:cNvPr id="4" name="Slide Number Placeholder 3"/>
+          <p:cNvSpPr>
+            <a:spLocks noGrp="1"/>
+          </p:cNvSpPr>
+          <p:nvPr>
+            <p:ph type="sldNum" idx="5" sz="quarter"/>
+          </p:nvPr>
+        </p:nvSpPr>
+        <p:spPr/>
+      </p:sp>
+    </p:spTree>
+  </p:cSld>
+  <p:clrMapOvr>
+    <a:masterClrMapping/>
+  </p:clrMapOvr>
+</p:notes>
+</file>
+
+<file path=ppt/notesSlides/notesSlide3.xml><?xml version="1.0" encoding="utf-8"?>
+<p:notes xmlns:a="http://schemas.openxmlformats.org/drawingml/2006/main" xmlns:p="http://schemas.openxmlformats.org/presentationml/2006/main" xmlns:r="http://schemas.openxmlformats.org/officeDocument/2006/relationships">
+  <p:cSld>
+    <p:spTree>
+      <p:nvGrpSpPr>
+        <p:cNvPr id="1" name=""/>
+        <p:cNvGrpSpPr/>
+        <p:nvPr/>
+      </p:nvGrpSpPr>
+      <p:grpSpPr>
+        <a:xfrm>
+          <a:off x="0" y="0"/>
+          <a:ext cx="0" cy="0"/>
+          <a:chOff x="0" y="0"/>
+          <a:chExt cx="0" cy="0"/>
+        </a:xfrm>
+      </p:grpSpPr>
+      <p:sp>
+        <p:nvSpPr>
+          <p:cNvPr id="2" name="Slide Image Placeholder 1"/>
+          <p:cNvSpPr>
+            <a:spLocks noGrp="1"/>
+          </p:cNvSpPr>
+          <p:nvPr>
+            <p:ph type="sldImg" idx="2"/>
+          </p:nvPr>
+        </p:nvSpPr>
+        <p:spPr/>
+      </p:sp>
+      <p:sp>
+        <p:nvSpPr>
+          <p:cNvPr id="3" name="Notes Placeholder 2"/>
+          <p:cNvSpPr>
+            <a:spLocks noGrp="1"/>
+          </p:cNvSpPr>
+          <p:nvPr>
+            <p:ph type="body" idx="3" sz="quarter"/>
+          </p:nvPr>
+        </p:nvSpPr>
+        <p:spPr/>
+        <p:txBody>
+          <a:bodyPr/>
+          <a:lstStyle/>
+          <a:p>
+            <a:r>
+              <a:t>Three test files illustrate the relationship between ARC quality and extraction depth:</a:t>
+            </a:r>
+          </a:p>
+          <a:p/>
+          <a:p>
+            <a:r>
+              <a:t>Synthetic (schema-org-wheat-full.json): A manually crafted input designed to cover every FAIRagro-required field. The resulting ARC is fully compliant; extraction gets everything. This proves the pipeline works when the input follows the rules.</a:t>
+            </a:r>
+          </a:p>
+          <a:p/>
+          <a:p>
+            <a:r>
+              <a:t>Real — Small (arc-ro-crate-dronflyover.json, &lt;10 MB): An actual agronomic ARC from the UC13 drone flyover. It follows the ISA Investigation → Study → Assay hierarchy but uses non-standard property names and missing optional fields. Result: partial extraction. Only fields that map unambiguously to the FAIRagro schema come through.</a:t>
+            </a:r>
+          </a:p>
+          <a:p/>
+          <a:p>
+            <a:r>
+              <a:t>Real — Large (arc-ro-crate-muenchenberg-lte.json, &gt;100 MB): A long-term experiment ARC from Müncheberg with 27+ assays but a flatter structure. Many domain-specific fields don’t match any FAIRagro template key. Result: basic harvest only — title, description, identifier, creator.</a:t>
+            </a:r>
+          </a:p>
+          <a:p/>
+          <a:p>
+            <a:r>
+              <a:t>The pattern is clear: compliance determines extraction depth. If an ARC follows the FAIRagro specification, you get full extraction. If not, you get the intersection of what’s present and what’s mappable.</a:t>
+            </a:r>
+          </a:p>
+        </p:txBody>
+      </p:sp>
+      <p:sp>
+        <p:nvSpPr>
+          <p:cNvPr id="4" name="Slide Number Placeholder 3"/>
+          <p:cNvSpPr>
+            <a:spLocks noGrp="1"/>
+          </p:cNvSpPr>
+          <p:nvPr>
+            <p:ph type="sldNum" idx="5" sz="quarter"/>
+          </p:nvPr>
+        </p:nvSpPr>
+        <p:spPr/>
+      </p:sp>
+    </p:spTree>
+  </p:cSld>
+  <p:clrMapOvr>
+    <a:masterClrMapping/>
+  </p:clrMapOvr>
+</p:notes>
+</file>
+
+<file path=ppt/notesSlides/notesSlide4.xml><?xml version="1.0" encoding="utf-8"?>
+<p:notes xmlns:a="http://schemas.openxmlformats.org/drawingml/2006/main" xmlns:p="http://schemas.openxmlformats.org/presentationml/2006/main" xmlns:r="http://schemas.openxmlformats.org/officeDocument/2006/relationships">
+  <p:cSld>
+    <p:spTree>
+      <p:nvGrpSpPr>
+        <p:cNvPr id="1" name=""/>
+        <p:cNvGrpSpPr/>
+        <p:nvPr/>
+      </p:nvGrpSpPr>
+      <p:grpSpPr>
+        <a:xfrm>
+          <a:off x="0" y="0"/>
+          <a:ext cx="0" cy="0"/>
+          <a:chOff x="0" y="0"/>
+          <a:chExt cx="0" cy="0"/>
+        </a:xfrm>
+      </p:grpSpPr>
+      <p:sp>
+        <p:nvSpPr>
+          <p:cNvPr id="2" name="Slide Image Placeholder 1"/>
+          <p:cNvSpPr>
+            <a:spLocks noGrp="1"/>
+          </p:cNvSpPr>
+          <p:nvPr>
+            <p:ph type="sldImg" idx="2"/>
+          </p:nvPr>
+        </p:nvSpPr>
+        <p:spPr/>
+      </p:sp>
+      <p:sp>
+        <p:nvSpPr>
+          <p:cNvPr id="3" name="Notes Placeholder 2"/>
+          <p:cNvSpPr>
+            <a:spLocks noGrp="1"/>
+          </p:cNvSpPr>
+          <p:nvPr>
+            <p:ph type="body" idx="3" sz="quarter"/>
+          </p:nvPr>
+        </p:nvSpPr>
+        <p:spPr/>
+        <p:txBody>
+          <a:bodyPr/>
+          <a:lstStyle/>
+          <a:p>
+            <a:r>
+              <a:t>Two real ARCs, one problem: same domain concepts at different graph depths.</a:t>
+            </a:r>
+          </a:p>
+          <a:p/>
+          <a:p>
+            <a:r>
+              <a:t>Drone Flyover (UC13):</a:t>
+            </a:r>
+          </a:p>
+          <a:p>
+            <a:r>
+              <a:t>Following the ISA hierarchy: Investigation → Study → Assay. Two Agrischemas concepts live at very different traversal depths:</a:t>
+            </a:r>
+          </a:p>
+          <a:p/>
+          <a:p>
+            <a:r>
+              <a:t>- sensorType is 1 hop from Assay via measurementMethod → DefinedTerm.</a:t>
+            </a:r>
+          </a:p>
+          <a:p>
+            <a:r>
+              <a:t>- cropSpecies is 4 hops from Study via about → LabProcess → object → Sample → additionalProperty → PropertyValue.</a:t>
+            </a:r>
+          </a:p>
+          <a:p/>
+          <a:p>
+            <a:r>
+              <a:t>The sensorType path is short and direct. The cropSpecies path requires traversing five nodes with specific predicates at each step. The parser must know the exact path — any deviation and it loses the concept.</a:t>
+            </a:r>
+          </a:p>
+        </p:txBody>
+      </p:sp>
+      <p:sp>
+        <p:nvSpPr>
+          <p:cNvPr id="4" name="Slide Number Placeholder 3"/>
+          <p:cNvSpPr>
+            <a:spLocks noGrp="1"/>
+          </p:cNvSpPr>
+          <p:nvPr>
+            <p:ph type="sldNum" idx="5" sz="quarter"/>
+          </p:nvPr>
+        </p:nvSpPr>
+        <p:spPr/>
+      </p:sp>
+    </p:spTree>
+  </p:cSld>
+  <p:clrMapOvr>
+    <a:masterClrMapping/>
+  </p:clrMapOvr>
+</p:notes>
+</file>
+
+<file path=ppt/notesSlides/notesSlide5.xml><?xml version="1.0" encoding="utf-8"?>
+<p:notes xmlns:a="http://schemas.openxmlformats.org/drawingml/2006/main" xmlns:p="http://schemas.openxmlformats.org/presentationml/2006/main" xmlns:r="http://schemas.openxmlformats.org/officeDocument/2006/relationships">
+  <p:cSld>
+    <p:spTree>
+      <p:nvGrpSpPr>
+        <p:cNvPr id="1" name=""/>
+        <p:cNvGrpSpPr/>
+        <p:nvPr/>
+      </p:nvGrpSpPr>
+      <p:grpSpPr>
+        <a:xfrm>
+          <a:off x="0" y="0"/>
+          <a:ext cx="0" cy="0"/>
+          <a:chOff x="0" y="0"/>
+          <a:chExt cx="0" cy="0"/>
+        </a:xfrm>
+      </p:grpSpPr>
+      <p:sp>
+        <p:nvSpPr>
+          <p:cNvPr id="2" name="Slide Image Placeholder 1"/>
+          <p:cNvSpPr>
+            <a:spLocks noGrp="1"/>
+          </p:cNvSpPr>
+          <p:nvPr>
+            <p:ph type="sldImg" idx="2"/>
+          </p:nvPr>
+        </p:nvSpPr>
+        <p:spPr/>
+      </p:sp>
+      <p:sp>
+        <p:nvSpPr>
+          <p:cNvPr id="3" name="Notes Placeholder 2"/>
+          <p:cNvSpPr>
+            <a:spLocks noGrp="1"/>
+          </p:cNvSpPr>
+          <p:nvPr>
+            <p:ph type="body" idx="3" sz="quarter"/>
+          </p:nvPr>
+        </p:nvSpPr>
+        <p:spPr/>
+        <p:txBody>
+          <a:bodyPr/>
+          <a:lstStyle/>
+          <a:p>
+            <a:r>
+              <a:t>Müncheberg LTE:</a:t>
+            </a:r>
+          </a:p>
+          <a:p>
+            <a:r>
+              <a:t>A structurally different ARC. Investigation connects directly to 27+ Assays; a Study entity exists (studies/LTE-V140-Muencheberg/) but is NOT linked via the Investigation’s hasPart chain. Crop species surfaces via a shorter alternative path: Source → additionalProperty → CharacteristicValue (2 hops instead of 4). Müncheberg also has the same long LabProcess chain as the drone flyover (via Study.about → LabProcess → object → Source → additionalProperty), so both paths coexist. Sensor metadata is absent because this ARC is about crop phenology, not remote sensing.</a:t>
+            </a:r>
+          </a:p>
+          <a:p/>
+          <a:p>
+            <a:r>
+              <a:t>A generic parser cannot reliably extract crop species from both ARCs without knowing which structural pattern to apply. This variability is the core motivation for standardization.</a:t>
+            </a:r>
+          </a:p>
+        </p:txBody>
+      </p:sp>
+      <p:sp>
+        <p:nvSpPr>
+          <p:cNvPr id="4" name="Slide Number Placeholder 3"/>
+          <p:cNvSpPr>
+            <a:spLocks noGrp="1"/>
+          </p:cNvSpPr>
+          <p:nvPr>
+            <p:ph type="sldNum" idx="5" sz="quarter"/>
+          </p:nvPr>
+        </p:nvSpPr>
+        <p:spPr/>
+      </p:sp>
+    </p:spTree>
+  </p:cSld>
+  <p:clrMapOvr>
+    <a:masterClrMapping/>
+  </p:clrMapOvr>
+</p:notes>
+</file>
+
+<file path=ppt/notesSlides/notesSlide6.xml><?xml version="1.0" encoding="utf-8"?>
+<p:notes xmlns:a="http://schemas.openxmlformats.org/drawingml/2006/main" xmlns:p="http://schemas.openxmlformats.org/presentationml/2006/main" xmlns:r="http://schemas.openxmlformats.org/officeDocument/2006/relationships">
+  <p:cSld>
+    <p:spTree>
+      <p:nvGrpSpPr>
+        <p:cNvPr id="1" name=""/>
+        <p:cNvGrpSpPr/>
+        <p:nvPr/>
+      </p:nvGrpSpPr>
+      <p:grpSpPr>
+        <a:xfrm>
+          <a:off x="0" y="0"/>
+          <a:ext cx="0" cy="0"/>
+          <a:chOff x="0" y="0"/>
+          <a:chExt cx="0" cy="0"/>
+        </a:xfrm>
+      </p:grpSpPr>
+      <p:sp>
+        <p:nvSpPr>
+          <p:cNvPr id="2" name="Slide Image Placeholder 1"/>
+          <p:cNvSpPr>
+            <a:spLocks noGrp="1"/>
+          </p:cNvSpPr>
+          <p:nvPr>
+            <p:ph type="sldImg" idx="2"/>
+          </p:nvPr>
+        </p:nvSpPr>
+        <p:spPr/>
+      </p:sp>
+      <p:sp>
+        <p:nvSpPr>
+          <p:cNvPr id="3" name="Notes Placeholder 2"/>
+          <p:cNvSpPr>
+            <a:spLocks noGrp="1"/>
+          </p:cNvSpPr>
+          <p:nvPr>
+            <p:ph type="body" idx="3" sz="quarter"/>
+          </p:nvPr>
+        </p:nvSpPr>
+        <p:spPr/>
+        <p:txBody>
+          <a:bodyPr/>
+          <a:lstStyle/>
+          <a:p>
+            <a:r>
+              <a:t>After examining both ARCs, a required traversal path emerges for unambiguous crop extraction:</a:t>
+            </a:r>
+          </a:p>
+          <a:p/>
+          <a:p>
+            <a:r>
+              <a:t>Study → about → LabProcess → object → Sample/additionalType:Material</a:t>
+            </a:r>
+          </a:p>
+          <a:p>
+            <a:r>
+              <a:t>  → additionalProperty → PropertyValue/propertyID</a:t>
+            </a:r>
+          </a:p>
+          <a:p/>
+          <a:p>
+            <a:r>
+              <a:t>The terminal node — PropertyValue with a propertyID — is critical. name: Organism and value: Solanum tuberosum are human-readable but machine-ambiguous. The propertyID linking to an ontology term (e.g., agrovoc:c_49904) makes it semantically precise and machine-resolvable.</a:t>
+            </a:r>
+          </a:p>
+          <a:p/>
+          <a:p>
+            <a:r>
+              <a:t>Two open questions remain:</a:t>
+            </a:r>
+          </a:p>
+          <a:p/>
+          <a:p>
+            <a:r>
+              <a:t>1. Structure specification. How do we formally specify a required graph traversal path so that tools can validate compliance automatically? A shape expression (ShEx) or SHACL shape? A simple property-path DSL in the pivot registry YAML?</a:t>
+            </a:r>
+          </a:p>
+          <a:p/>
+          <a:p>
+            <a:r>
+              <a:t>2. Ontology mapping standardization. propertyID values need a shared vocabulary of mappings so that every ARC uses the same ontology term for “crop species.” SSSOM (Simple Standard for Sharing Ontological Mappings) is a candidate — but it needs community adoption.</a:t>
+            </a:r>
+          </a:p>
+          <a:p/>
+          <a:p>
+            <a:r>
+              <a:t>These are not FAIRweaver problems. They are community-level standardization problems that FAIRweaver exposes and quantifies.</a:t>
+            </a:r>
+          </a:p>
+        </p:txBody>
+      </p:sp>
+      <p:sp>
+        <p:nvSpPr>
+          <p:cNvPr id="4" name="Slide Number Placeholder 3"/>
+          <p:cNvSpPr>
+            <a:spLocks noGrp="1"/>
+          </p:cNvSpPr>
+          <p:nvPr>
+            <p:ph type="sldNum" idx="5" sz="quarter"/>
+          </p:nvPr>
+        </p:nvSpPr>
+        <p:spPr/>
+      </p:sp>
+    </p:spTree>
+  </p:cSld>
+  <p:clrMapOvr>
+    <a:masterClrMapping/>
+  </p:clrMapOvr>
+</p:notes>
 </file>
 
 <file path=ppt/slideLayouts/slideLayout1.xml><?xml version="1.0" encoding="utf-8"?>
@@ -3125,7 +4041,7 @@
                 </a:solidFill>
                 <a:latin typeface="Calibri"/>
               </a:rPr>
-              <a:t>FAIRweaver: Schema.org → ARC → FAIRagro Workflow</a:t>
+              <a:t>Schema.org → ARC → FAIRagro Workflow</a:t>
             </a:r>
           </a:p>
         </p:txBody>
@@ -3212,35 +4128,89 @@
                 </a:solidFill>
                 <a:latin typeface="Calibri"/>
               </a:rPr>
-              <a:t>Slide 1 — FAIRagro Metadata Transformation Pipeline</a:t>
-            </a:r>
-          </a:p>
-        </p:txBody>
-      </p:sp>
-      <p:pic>
-        <p:nvPicPr>
-          <p:cNvPr id="3" name="Picture 2" descr="slide1-pipeline.png"/>
-          <p:cNvPicPr>
-            <a:picLocks noChangeAspect="1"/>
-          </p:cNvPicPr>
+              <a:t>FAIRagro Metadata Transformation Pipeline</a:t>
+            </a:r>
+          </a:p>
+        </p:txBody>
+      </p:sp>
+      <p:sp>
+        <p:nvSpPr>
+          <p:cNvPr id="3" name="TextBox 2"/>
+          <p:cNvSpPr txBox="1"/>
           <p:nvPr/>
-        </p:nvPicPr>
-        <p:blipFill>
-          <a:blip r:embed="rId2"/>
-          <a:stretch>
-            <a:fillRect/>
-          </a:stretch>
-        </p:blipFill>
+        </p:nvSpPr>
         <p:spPr>
           <a:xfrm>
             <a:off x="457200" y="1371600"/>
-            <a:ext cx="10972800" cy="1881316"/>
+            <a:ext cx="10972800" cy="4572000"/>
           </a:xfrm>
           <a:prstGeom prst="rect">
             <a:avLst/>
           </a:prstGeom>
+          <a:noFill/>
         </p:spPr>
-      </p:pic>
+        <p:txBody>
+          <a:bodyPr wrap="square">
+            <a:spAutoFit/>
+          </a:bodyPr>
+          <a:lstStyle/>
+          <a:p>
+            <a:r>
+              <a:rPr sz="1600" b="0">
+                <a:solidFill>
+                  <a:srgbClr val="000000"/>
+                </a:solidFill>
+                <a:latin typeface="Calibri"/>
+              </a:rPr>
+              <a:t>Sequential dependency: Output B (FAIRagro JSON) is derived from Output A (ARC RO-Crate) — not a parallel output</a:t>
+            </a:r>
+          </a:p>
+          <a:p>
+            <a:r>
+              <a:rPr sz="1600" b="0">
+                <a:solidFill>
+                  <a:srgbClr val="000000"/>
+                </a:solidFill>
+                <a:latin typeface="Calibri"/>
+              </a:rPr>
+              <a:t>Two harvest paths converge on the same FAIRagro JSON schema:</a:t>
+            </a:r>
+          </a:p>
+          <a:p>
+            <a:r>
+              <a:rPr sz="1600" b="0">
+                <a:solidFill>
+                  <a:srgbClr val="000000"/>
+                </a:solidFill>
+                <a:latin typeface="Calibri"/>
+              </a:rPr>
+              <a:t>  • Path 1 (solid): Direct harvest from GitLab DataHub where ARCs are stored</a:t>
+            </a:r>
+          </a:p>
+          <a:p>
+            <a:r>
+              <a:rPr sz="1600" b="0">
+                <a:solidFill>
+                  <a:srgbClr val="000000"/>
+                </a:solidFill>
+                <a:latin typeface="Calibri"/>
+              </a:rPr>
+              <a:t>  • Path 2 (dashed): Via FAIRagro Middleware API (federated service)</a:t>
+            </a:r>
+          </a:p>
+          <a:p>
+            <a:r>
+              <a:rPr sz="1600" b="0">
+                <a:solidFill>
+                  <a:srgbClr val="000000"/>
+                </a:solidFill>
+                <a:latin typeface="Calibri"/>
+              </a:rPr>
+              <a:t>Both paths produce identical FAIRagro schema.json ingested into SearchHub</a:t>
+            </a:r>
+          </a:p>
+        </p:txBody>
+      </p:sp>
     </p:spTree>
   </p:cSld>
   <p:clrMapOvr>
@@ -3288,142 +4258,7 @@
                 </a:solidFill>
                 <a:latin typeface="Calibri"/>
               </a:rPr>
-              <a:t>Slide 1 — Key Points</a:t>
-            </a:r>
-          </a:p>
-        </p:txBody>
-      </p:sp>
-      <p:sp>
-        <p:nvSpPr>
-          <p:cNvPr id="3" name="TextBox 2"/>
-          <p:cNvSpPr txBox="1"/>
-          <p:nvPr/>
-        </p:nvSpPr>
-        <p:spPr>
-          <a:xfrm>
-            <a:off x="457200" y="1371600"/>
-            <a:ext cx="10972800" cy="4572000"/>
-          </a:xfrm>
-          <a:prstGeom prst="rect">
-            <a:avLst/>
-          </a:prstGeom>
-          <a:noFill/>
-        </p:spPr>
-        <p:txBody>
-          <a:bodyPr wrap="square">
-            <a:spAutoFit/>
-          </a:bodyPr>
-          <a:lstStyle/>
-          <a:p>
-            <a:pPr/>
-            <a:r>
-              <a:rPr sz="1600" b="0">
-                <a:solidFill>
-                  <a:srgbClr val="000000"/>
-                </a:solidFill>
-                <a:latin typeface="Calibri"/>
-              </a:rPr>
-              <a:t>Sequential dependency: Output B (FAIRagro JSON) is derived from Output A (ARC RO-Crate) — not a parallel output</a:t>
-            </a:r>
-          </a:p>
-          <a:p>
-            <a:pPr/>
-            <a:r>
-              <a:rPr sz="1600" b="0">
-                <a:solidFill>
-                  <a:srgbClr val="000000"/>
-                </a:solidFill>
-                <a:latin typeface="Calibri"/>
-              </a:rPr>
-              <a:t>Two harvest paths converge on the same FAIRagro JSON schema:</a:t>
-            </a:r>
-          </a:p>
-          <a:p>
-            <a:pPr/>
-            <a:r>
-              <a:rPr sz="1600" b="0">
-                <a:solidFill>
-                  <a:srgbClr val="000000"/>
-                </a:solidFill>
-                <a:latin typeface="Calibri"/>
-              </a:rPr>
-              <a:t>  • Path 1 (solid): Direct harvest from GitLab DataHub where ARCs are stored</a:t>
-            </a:r>
-          </a:p>
-          <a:p>
-            <a:pPr/>
-            <a:r>
-              <a:rPr sz="1600" b="0">
-                <a:solidFill>
-                  <a:srgbClr val="000000"/>
-                </a:solidFill>
-                <a:latin typeface="Calibri"/>
-              </a:rPr>
-              <a:t>  • Path 2 (dashed): Via FAIRagro Middleware API (federated service)</a:t>
-            </a:r>
-          </a:p>
-          <a:p>
-            <a:pPr/>
-            <a:r>
-              <a:rPr sz="1600" b="0">
-                <a:solidFill>
-                  <a:srgbClr val="000000"/>
-                </a:solidFill>
-                <a:latin typeface="Calibri"/>
-              </a:rPr>
-              <a:t>Both paths produce identical FAIRagro schema.json ingested into SearchHub</a:t>
-            </a:r>
-          </a:p>
-        </p:txBody>
-      </p:sp>
-    </p:spTree>
-  </p:cSld>
-  <p:clrMapOvr>
-    <a:masterClrMapping/>
-  </p:clrMapOvr>
-</p:sld>
-</file>
-
-<file path=ppt/slides/slide4.xml><?xml version="1.0" encoding="utf-8"?>
-<p:sld xmlns:a="http://schemas.openxmlformats.org/drawingml/2006/main" xmlns:p="http://schemas.openxmlformats.org/presentationml/2006/main" xmlns:r="http://schemas.openxmlformats.org/officeDocument/2006/relationships">
-  <p:cSld>
-    <p:spTree>
-      <p:nvGrpSpPr>
-        <p:cNvPr id="1" name=""/>
-        <p:cNvGrpSpPr/>
-        <p:nvPr/>
-      </p:nvGrpSpPr>
-      <p:grpSpPr/>
-      <p:sp>
-        <p:nvSpPr>
-          <p:cNvPr id="2" name="TextBox 1"/>
-          <p:cNvSpPr txBox="1"/>
-          <p:nvPr/>
-        </p:nvSpPr>
-        <p:spPr>
-          <a:xfrm>
-            <a:off x="457200" y="274320"/>
-            <a:ext cx="10972800" cy="731520"/>
-          </a:xfrm>
-          <a:prstGeom prst="rect">
-            <a:avLst/>
-          </a:prstGeom>
-          <a:noFill/>
-        </p:spPr>
-        <p:txBody>
-          <a:bodyPr wrap="square">
-            <a:spAutoFit/>
-          </a:bodyPr>
-          <a:lstStyle/>
-          <a:p>
-            <a:r>
-              <a:rPr sz="2800" b="1">
-                <a:solidFill>
-                  <a:srgbClr val="1565C0"/>
-                </a:solidFill>
-                <a:latin typeface="Calibri"/>
-              </a:rPr>
-              <a:t>Slide 2 — Three File Scenarios: Input → ARC → FAIRagro Output</a:t>
+              <a:t>Three File Scenarios: Input → ARC → FAIRagro Output</a:t>
             </a:r>
           </a:p>
         </p:txBody>
@@ -3811,7 +4646,7 @@
 </p:sld>
 </file>
 
-<file path=ppt/slides/slide5.xml><?xml version="1.0" encoding="utf-8"?>
+<file path=ppt/slides/slide4.xml><?xml version="1.0" encoding="utf-8"?>
 <p:sld xmlns:a="http://schemas.openxmlformats.org/drawingml/2006/main" xmlns:p="http://schemas.openxmlformats.org/presentationml/2006/main" xmlns:r="http://schemas.openxmlformats.org/officeDocument/2006/relationships">
   <p:cSld>
     <p:spTree>
@@ -3850,7 +4685,7 @@
                 </a:solidFill>
                 <a:latin typeface="Calibri"/>
               </a:rPr>
-              <a:t>Slide 3 — Examining ARC Structure: Domain Objects at Different Depths</a:t>
+              <a:t>Examining ARC Structure: Domain Objects at Different Depths</a:t>
             </a:r>
           </a:p>
         </p:txBody>
@@ -3877,7 +4712,6 @@
           </a:bodyPr>
           <a:lstStyle/>
           <a:p>
-            <a:pPr/>
             <a:r>
               <a:rPr sz="1600" b="0">
                 <a:solidFill>
@@ -3889,7 +4723,6 @@
             </a:r>
           </a:p>
           <a:p>
-            <a:pPr/>
             <a:r>
               <a:rPr sz="1600" b="0">
                 <a:solidFill>
@@ -3897,11 +4730,10 @@
                 </a:solidFill>
                 <a:latin typeface="Calibri"/>
               </a:rPr>
-              <a:t>• Understand how Agrischemas concepts map into ARC RO-Crate</a:t>
-            </a:r>
-          </a:p>
-          <a:p>
-            <a:pPr/>
+              <a:t>  • Understand how Agrischemas concepts map into ARC RO-Crate</a:t>
+            </a:r>
+          </a:p>
+          <a:p>
             <a:r>
               <a:rPr sz="1600" b="0">
                 <a:solidFill>
@@ -3909,7 +4741,7 @@
                 </a:solidFill>
                 <a:latin typeface="Calibri"/>
               </a:rPr>
-              <a:t>• Show that equivalent domain concepts require very different traversal depths</a:t>
+              <a:t>  • Show that equivalent domain concepts require very different traversal depths</a:t>
             </a:r>
           </a:p>
         </p:txBody>
@@ -3981,7 +4813,7 @@
 </p:sld>
 </file>
 
-<file path=ppt/slides/slide6.xml><?xml version="1.0" encoding="utf-8"?>
+<file path=ppt/slides/slide5.xml><?xml version="1.0" encoding="utf-8"?>
 <p:sld xmlns:a="http://schemas.openxmlformats.org/drawingml/2006/main" xmlns:p="http://schemas.openxmlformats.org/presentationml/2006/main" xmlns:r="http://schemas.openxmlformats.org/officeDocument/2006/relationships">
   <p:cSld>
     <p:spTree>
@@ -4020,7 +4852,7 @@
                 </a:solidFill>
                 <a:latin typeface="Calibri"/>
               </a:rPr>
-              <a:t>Slide 4 — Müncheberg ARC: A Different Structural Pattern</a:t>
+              <a:t>Müncheberg ARC: A Different Structural Pattern</a:t>
             </a:r>
           </a:p>
         </p:txBody>
@@ -4034,7 +4866,7 @@
         <p:spPr>
           <a:xfrm>
             <a:off x="457200" y="1188720"/>
-            <a:ext cx="10972800" cy="1371600"/>
+            <a:ext cx="10972800" cy="1097280"/>
           </a:xfrm>
           <a:prstGeom prst="rect">
             <a:avLst/>
@@ -4047,7 +4879,6 @@
           </a:bodyPr>
           <a:lstStyle/>
           <a:p>
-            <a:pPr/>
             <a:r>
               <a:rPr sz="1600" b="0">
                 <a:solidFill>
@@ -4059,7 +4890,6 @@
             </a:r>
           </a:p>
           <a:p>
-            <a:pPr/>
             <a:r>
               <a:rPr sz="1600" b="0">
                 <a:solidFill>
@@ -4067,11 +4897,10 @@
                 </a:solidFill>
                 <a:latin typeface="Calibri"/>
               </a:rPr>
-              <a:t>• Show another real ARC with a different structural pattern</a:t>
-            </a:r>
-          </a:p>
-          <a:p>
-            <a:pPr/>
+              <a:t>  • Show another real ARC with a different structural pattern</a:t>
+            </a:r>
+          </a:p>
+          <a:p>
             <a:r>
               <a:rPr sz="1600" b="0">
                 <a:solidFill>
@@ -4079,7 +4908,7 @@
                 </a:solidFill>
                 <a:latin typeface="Calibri"/>
               </a:rPr>
-              <a:t>• Reinforce that parser must handle multiple modeling conventions</a:t>
+              <a:t>  • Reinforce that parser must handle multiple modeling conventions</a:t>
             </a:r>
           </a:p>
         </p:txBody>
@@ -4100,8 +4929,8 @@
         </p:blipFill>
         <p:spPr>
           <a:xfrm>
-            <a:off x="1371600" y="2560320"/>
-            <a:ext cx="9144000" cy="3320878"/>
+            <a:off x="3200400" y="2103120"/>
+            <a:ext cx="8229600" cy="2988791"/>
           </a:xfrm>
           <a:prstGeom prst="rect">
             <a:avLst/>
@@ -4143,69 +4972,17 @@
           </a:p>
         </p:txBody>
       </p:sp>
-    </p:spTree>
-  </p:cSld>
-  <p:clrMapOvr>
-    <a:masterClrMapping/>
-  </p:clrMapOvr>
-</p:sld>
-</file>
-
-<file path=ppt/slides/slide7.xml><?xml version="1.0" encoding="utf-8"?>
-<p:sld xmlns:a="http://schemas.openxmlformats.org/drawingml/2006/main" xmlns:p="http://schemas.openxmlformats.org/presentationml/2006/main" xmlns:r="http://schemas.openxmlformats.org/officeDocument/2006/relationships">
-  <p:cSld>
-    <p:spTree>
-      <p:nvGrpSpPr>
-        <p:cNvPr id="1" name=""/>
-        <p:cNvGrpSpPr/>
-        <p:nvPr/>
-      </p:nvGrpSpPr>
-      <p:grpSpPr/>
-      <p:sp>
-        <p:nvSpPr>
-          <p:cNvPr id="2" name="TextBox 1"/>
-          <p:cNvSpPr txBox="1"/>
-          <p:nvPr/>
-        </p:nvSpPr>
-        <p:spPr>
-          <a:xfrm>
-            <a:off x="457200" y="274320"/>
-            <a:ext cx="10972800" cy="731520"/>
-          </a:xfrm>
-          <a:prstGeom prst="rect">
-            <a:avLst/>
-          </a:prstGeom>
-          <a:noFill/>
-        </p:spPr>
-        <p:txBody>
-          <a:bodyPr wrap="square">
-            <a:spAutoFit/>
-          </a:bodyPr>
-          <a:lstStyle/>
-          <a:p>
-            <a:r>
-              <a:rPr sz="2800" b="1">
-                <a:solidFill>
-                  <a:srgbClr val="1565C0"/>
-                </a:solidFill>
-                <a:latin typeface="Calibri"/>
-              </a:rPr>
-              <a:t>Slide 4 — Comparison: Drone Flyover vs Müncheberg</a:t>
-            </a:r>
-          </a:p>
-        </p:txBody>
-      </p:sp>
       <p:graphicFrame>
         <p:nvGraphicFramePr>
-          <p:cNvPr id="3" name="Table 2"/>
+          <p:cNvPr id="6" name="Table 5"/>
           <p:cNvGraphicFramePr>
             <a:graphicFrameLocks noGrp="1"/>
           </p:cNvGraphicFramePr>
           <p:nvPr/>
         </p:nvGraphicFramePr>
         <p:xfrm>
-          <a:off x="457200" y="1371600"/>
-          <a:ext cx="10972800" cy="3200400"/>
+          <a:off x="457200" y="3200400"/>
+          <a:ext cx="10972800" cy="2743200"/>
         </p:xfrm>
         <a:graphic>
           <a:graphicData uri="http://schemas.openxmlformats.org/drawingml/2006/table">
@@ -4218,7 +4995,7 @@
                 <a:gridCol w="3657600"/>
                 <a:gridCol w="3657600"/>
               </a:tblGrid>
-              <a:tr h="533400">
+              <a:tr h="457200">
                 <a:tc>
                   <a:txBody>
                     <a:bodyPr/>
@@ -4286,7 +5063,7 @@
                   </a:tcPr>
                 </a:tc>
               </a:tr>
-              <a:tr h="533400">
+              <a:tr h="457200">
                 <a:tc>
                   <a:txBody>
                     <a:bodyPr/>
@@ -4342,7 +5119,7 @@
                   <a:tcPr/>
                 </a:tc>
               </a:tr>
-              <a:tr h="533400">
+              <a:tr h="457200">
                 <a:tc>
                   <a:txBody>
                     <a:bodyPr/>
@@ -4398,7 +5175,7 @@
                   <a:tcPr/>
                 </a:tc>
               </a:tr>
-              <a:tr h="533400">
+              <a:tr h="457200">
                 <a:tc>
                   <a:txBody>
                     <a:bodyPr/>
@@ -4454,7 +5231,7 @@
                   <a:tcPr/>
                 </a:tc>
               </a:tr>
-              <a:tr h="533400">
+              <a:tr h="457200">
                 <a:tc>
                   <a:txBody>
                     <a:bodyPr/>
@@ -4510,7 +5287,7 @@
                   <a:tcPr/>
                 </a:tc>
               </a:tr>
-              <a:tr h="533400">
+              <a:tr h="457200">
                 <a:tc>
                   <a:txBody>
                     <a:bodyPr/>
@@ -4578,7 +5355,7 @@
 </p:sld>
 </file>
 
-<file path=ppt/slides/slide8.xml><?xml version="1.0" encoding="utf-8"?>
+<file path=ppt/slides/slide6.xml><?xml version="1.0" encoding="utf-8"?>
 <p:sld xmlns:a="http://schemas.openxmlformats.org/drawingml/2006/main" xmlns:p="http://schemas.openxmlformats.org/presentationml/2006/main" xmlns:r="http://schemas.openxmlformats.org/officeDocument/2006/relationships">
   <p:cSld>
     <p:spTree>
@@ -4617,7 +5394,7 @@
                 </a:solidFill>
                 <a:latin typeface="Calibri"/>
               </a:rPr>
-              <a:t>Slide 5 — Required Modeling Pattern &amp; Standardization Gap</a:t>
+              <a:t>Required Modeling Pattern &amp; Standardization Gap</a:t>
             </a:r>
           </a:p>
         </p:txBody>
@@ -4631,7 +5408,7 @@
         <p:spPr>
           <a:xfrm>
             <a:off x="457200" y="1188720"/>
-            <a:ext cx="10972800" cy="1371600"/>
+            <a:ext cx="10972800" cy="1097280"/>
           </a:xfrm>
           <a:prstGeom prst="rect">
             <a:avLst/>
@@ -4644,7 +5421,6 @@
           </a:bodyPr>
           <a:lstStyle/>
           <a:p>
-            <a:pPr/>
             <a:r>
               <a:rPr sz="1600" b="0">
                 <a:solidFill>
@@ -4656,7 +5432,6 @@
             </a:r>
           </a:p>
           <a:p>
-            <a:pPr/>
             <a:r>
               <a:rPr sz="1600" b="0">
                 <a:solidFill>
@@ -4664,11 +5439,10 @@
                 </a:solidFill>
                 <a:latin typeface="Calibri"/>
               </a:rPr>
-              <a:t>• Define the required path for unambiguous extraction</a:t>
-            </a:r>
-          </a:p>
-          <a:p>
-            <a:pPr/>
+              <a:t>  • Define the required path for unambiguous extraction</a:t>
+            </a:r>
+          </a:p>
+          <a:p>
             <a:r>
               <a:rPr sz="1600" b="0">
                 <a:solidFill>
@@ -4676,7 +5450,7 @@
                 </a:solidFill>
                 <a:latin typeface="Calibri"/>
               </a:rPr>
-              <a:t>• Identify what still needs standardization</a:t>
+              <a:t>  • Identify what still needs standardization</a:t>
             </a:r>
           </a:p>
         </p:txBody>
@@ -4697,8 +5471,8 @@
         </p:blipFill>
         <p:spPr>
           <a:xfrm>
-            <a:off x="1371600" y="2560320"/>
-            <a:ext cx="9144000" cy="13195139"/>
+            <a:off x="3200400" y="2103120"/>
+            <a:ext cx="7315200" cy="10556111"/>
           </a:xfrm>
           <a:prstGeom prst="rect">
             <a:avLst/>
@@ -4713,7 +5487,7 @@
         </p:nvSpPr>
         <p:spPr>
           <a:xfrm>
-            <a:off x="457200" y="5943600"/>
+            <a:off x="457200" y="5303520"/>
             <a:ext cx="10972800" cy="457200"/>
           </a:xfrm>
           <a:prstGeom prst="rect">
@@ -4748,7 +5522,7 @@
         </p:nvSpPr>
         <p:spPr>
           <a:xfrm>
-            <a:off x="457200" y="6217920"/>
+            <a:off x="457200" y="5577840"/>
             <a:ext cx="10972800" cy="457200"/>
           </a:xfrm>
           <a:prstGeom prst="rect">
@@ -4775,69 +5549,17 @@
           </a:p>
         </p:txBody>
       </p:sp>
-    </p:spTree>
-  </p:cSld>
-  <p:clrMapOvr>
-    <a:masterClrMapping/>
-  </p:clrMapOvr>
-</p:sld>
-</file>
-
-<file path=ppt/slides/slide9.xml><?xml version="1.0" encoding="utf-8"?>
-<p:sld xmlns:a="http://schemas.openxmlformats.org/drawingml/2006/main" xmlns:p="http://schemas.openxmlformats.org/presentationml/2006/main" xmlns:r="http://schemas.openxmlformats.org/officeDocument/2006/relationships">
-  <p:cSld>
-    <p:spTree>
-      <p:nvGrpSpPr>
-        <p:cNvPr id="1" name=""/>
-        <p:cNvGrpSpPr/>
-        <p:nvPr/>
-      </p:nvGrpSpPr>
-      <p:grpSpPr/>
-      <p:sp>
-        <p:nvSpPr>
-          <p:cNvPr id="2" name="TextBox 1"/>
-          <p:cNvSpPr txBox="1"/>
-          <p:nvPr/>
-        </p:nvSpPr>
-        <p:spPr>
-          <a:xfrm>
-            <a:off x="457200" y="274320"/>
-            <a:ext cx="10972800" cy="731520"/>
-          </a:xfrm>
-          <a:prstGeom prst="rect">
-            <a:avLst/>
-          </a:prstGeom>
-          <a:noFill/>
-        </p:spPr>
-        <p:txBody>
-          <a:bodyPr wrap="square">
-            <a:spAutoFit/>
-          </a:bodyPr>
-          <a:lstStyle/>
-          <a:p>
-            <a:r>
-              <a:rPr sz="2800" b="1">
-                <a:solidFill>
-                  <a:srgbClr val="1565C0"/>
-                </a:solidFill>
-                <a:latin typeface="Calibri"/>
-              </a:rPr>
-              <a:t>Slide 5 — Open Questions</a:t>
-            </a:r>
-          </a:p>
-        </p:txBody>
-      </p:sp>
       <p:graphicFrame>
         <p:nvGraphicFramePr>
-          <p:cNvPr id="3" name="Table 2"/>
+          <p:cNvPr id="7" name="Table 6"/>
           <p:cNvGraphicFramePr>
             <a:graphicFrameLocks noGrp="1"/>
           </p:cNvGraphicFramePr>
           <p:nvPr/>
         </p:nvGraphicFramePr>
         <p:xfrm>
-          <a:off x="457200" y="1371600"/>
-          <a:ext cx="10972800" cy="1828800"/>
+          <a:off x="457200" y="5852160"/>
+          <a:ext cx="10972800" cy="822960"/>
         </p:xfrm>
         <a:graphic>
           <a:graphicData uri="http://schemas.openxmlformats.org/drawingml/2006/table">
@@ -4849,7 +5571,7 @@
                 <a:gridCol w="5486400"/>
                 <a:gridCol w="5486400"/>
               </a:tblGrid>
-              <a:tr h="609600">
+              <a:tr h="274320">
                 <a:tc>
                   <a:txBody>
                     <a:bodyPr/>
@@ -4895,7 +5617,7 @@
                   </a:tcPr>
                 </a:tc>
               </a:tr>
-              <a:tr h="609600">
+              <a:tr h="274320">
                 <a:tc>
                   <a:txBody>
                     <a:bodyPr/>
@@ -4933,7 +5655,7 @@
                   <a:tcPr/>
                 </a:tc>
               </a:tr>
-              <a:tr h="609600">
+              <a:tr h="274320">
                 <a:tc>
                   <a:txBody>
                     <a:bodyPr/>
@@ -5301,4 +6023,324 @@
   </a:objectDefaults>
   <a:extraClrSchemeLst/>
 </a:theme>
+</file>
+
+<file path=ppt/theme/theme2.xml><?xml version="1.0" encoding="utf-8"?>
+<a:theme xmlns:a="http://schemas.openxmlformats.org/drawingml/2006/main" name="Office Theme">
+  <a:themeElements>
+    <a:clrScheme name="Office">
+      <a:dk1>
+        <a:sysClr val="windowText" lastClr="000000"/>
+      </a:dk1>
+      <a:lt1>
+        <a:sysClr val="window" lastClr="FFFFFF"/>
+      </a:lt1>
+      <a:dk2>
+        <a:srgbClr val="1F497D"/>
+      </a:dk2>
+      <a:lt2>
+        <a:srgbClr val="EEECE1"/>
+      </a:lt2>
+      <a:accent1>
+        <a:srgbClr val="4F81BD"/>
+      </a:accent1>
+      <a:accent2>
+        <a:srgbClr val="C0504D"/>
+      </a:accent2>
+      <a:accent3>
+        <a:srgbClr val="9BBB59"/>
+      </a:accent3>
+      <a:accent4>
+        <a:srgbClr val="8064A2"/>
+      </a:accent4>
+      <a:accent5>
+        <a:srgbClr val="4BACC6"/>
+      </a:accent5>
+      <a:accent6>
+        <a:srgbClr val="F79646"/>
+      </a:accent6>
+      <a:hlink>
+        <a:srgbClr val="0000FF"/>
+      </a:hlink>
+      <a:folHlink>
+        <a:srgbClr val="800080"/>
+      </a:folHlink>
+    </a:clrScheme>
+    <a:fontScheme name="Office">
+      <a:majorFont>
+        <a:latin typeface="Calibri"/>
+        <a:ea typeface=""/>
+        <a:cs typeface=""/>
+        <a:font script="Jpan" typeface="ＭＳ Ｐゴシック"/>
+        <a:font script="Hang" typeface="맑은 고딕"/>
+        <a:font script="Hans" typeface="宋体"/>
+        <a:font script="Hant" typeface="新細明體"/>
+        <a:font script="Arab" typeface="Times New Roman"/>
+        <a:font script="Hebr" typeface="Times New Roman"/>
+        <a:font script="Thai" typeface="Angsana New"/>
+        <a:font script="Ethi" typeface="Nyala"/>
+        <a:font script="Beng" typeface="Vrinda"/>
+        <a:font script="Gujr" typeface="Shruti"/>
+        <a:font script="Khmr" typeface="MoolBoran"/>
+        <a:font script="Knda" typeface="Tunga"/>
+        <a:font script="Guru" typeface="Raavi"/>
+        <a:font script="Cans" typeface="Euphemia"/>
+        <a:font script="Cher" typeface="Plantagenet Cherokee"/>
+        <a:font script="Yiii" typeface="Microsoft Yi Baiti"/>
+        <a:font script="Tibt" typeface="Microsoft Himalaya"/>
+        <a:font script="Thaa" typeface="MV Boli"/>
+        <a:font script="Deva" typeface="Mangal"/>
+        <a:font script="Telu" typeface="Gautami"/>
+        <a:font script="Taml" typeface="Latha"/>
+        <a:font script="Syrc" typeface="Estrangelo Edessa"/>
+        <a:font script="Orya" typeface="Kalinga"/>
+        <a:font script="Mlym" typeface="Kartika"/>
+        <a:font script="Laoo" typeface="DokChampa"/>
+        <a:font script="Sinh" typeface="Iskoola Pota"/>
+        <a:font script="Mong" typeface="Mongolian Baiti"/>
+        <a:font script="Viet" typeface="Times New Roman"/>
+        <a:font script="Uigh" typeface="Microsoft Uighur"/>
+        <a:font script="Geor" typeface="Sylfaen"/>
+      </a:majorFont>
+      <a:minorFont>
+        <a:latin typeface="Calibri"/>
+        <a:ea typeface=""/>
+        <a:cs typeface=""/>
+        <a:font script="Jpan" typeface="ＭＳ Ｐゴシック"/>
+        <a:font script="Hang" typeface="맑은 고딕"/>
+        <a:font script="Hans" typeface="宋体"/>
+        <a:font script="Hant" typeface="新細明體"/>
+        <a:font script="Arab" typeface="Arial"/>
+        <a:font script="Hebr" typeface="Arial"/>
+        <a:font script="Thai" typeface="Cordia New"/>
+        <a:font script="Ethi" typeface="Nyala"/>
+        <a:font script="Beng" typeface="Vrinda"/>
+        <a:font script="Gujr" typeface="Shruti"/>
+        <a:font script="Khmr" typeface="DaunPenh"/>
+        <a:font script="Knda" typeface="Tunga"/>
+        <a:font script="Guru" typeface="Raavi"/>
+        <a:font script="Cans" typeface="Euphemia"/>
+        <a:font script="Cher" typeface="Plantagenet Cherokee"/>
+        <a:font script="Yiii" typeface="Microsoft Yi Baiti"/>
+        <a:font script="Tibt" typeface="Microsoft Himalaya"/>
+        <a:font script="Thaa" typeface="MV Boli"/>
+        <a:font script="Deva" typeface="Mangal"/>
+        <a:font script="Telu" typeface="Gautami"/>
+        <a:font script="Taml" typeface="Latha"/>
+        <a:font script="Syrc" typeface="Estrangelo Edessa"/>
+        <a:font script="Orya" typeface="Kalinga"/>
+        <a:font script="Mlym" typeface="Kartika"/>
+        <a:font script="Laoo" typeface="DokChampa"/>
+        <a:font script="Sinh" typeface="Iskoola Pota"/>
+        <a:font script="Mong" typeface="Mongolian Baiti"/>
+        <a:font script="Viet" typeface="Arial"/>
+        <a:font script="Uigh" typeface="Microsoft Uighur"/>
+        <a:font script="Geor" typeface="Sylfaen"/>
+      </a:minorFont>
+    </a:fontScheme>
+    <a:fmtScheme name="Office">
+      <a:fillStyleLst>
+        <a:solidFill>
+          <a:schemeClr val="phClr"/>
+        </a:solidFill>
+        <a:gradFill rotWithShape="1">
+          <a:gsLst>
+            <a:gs pos="0">
+              <a:schemeClr val="phClr">
+                <a:tint val="50000"/>
+                <a:satMod val="300000"/>
+              </a:schemeClr>
+            </a:gs>
+            <a:gs pos="35000">
+              <a:schemeClr val="phClr">
+                <a:tint val="37000"/>
+                <a:satMod val="300000"/>
+              </a:schemeClr>
+            </a:gs>
+            <a:gs pos="100000">
+              <a:schemeClr val="phClr">
+                <a:tint val="15000"/>
+                <a:satMod val="350000"/>
+              </a:schemeClr>
+            </a:gs>
+          </a:gsLst>
+          <a:lin ang="16200000" scaled="1"/>
+        </a:gradFill>
+        <a:gradFill rotWithShape="1">
+          <a:gsLst>
+            <a:gs pos="0">
+              <a:schemeClr val="phClr">
+                <a:tint val="100000"/>
+                <a:shade val="100000"/>
+                <a:satMod val="130000"/>
+              </a:schemeClr>
+            </a:gs>
+            <a:gs pos="100000">
+              <a:schemeClr val="phClr">
+                <a:tint val="50000"/>
+                <a:shade val="100000"/>
+                <a:satMod val="350000"/>
+              </a:schemeClr>
+            </a:gs>
+          </a:gsLst>
+          <a:lin ang="16200000" scaled="0"/>
+        </a:gradFill>
+      </a:fillStyleLst>
+      <a:lnStyleLst>
+        <a:ln w="9525" cap="flat" cmpd="sng" algn="ctr">
+          <a:solidFill>
+            <a:schemeClr val="phClr">
+              <a:shade val="95000"/>
+              <a:satMod val="105000"/>
+            </a:schemeClr>
+          </a:solidFill>
+          <a:prstDash val="solid"/>
+        </a:ln>
+        <a:ln w="25400" cap="flat" cmpd="sng" algn="ctr">
+          <a:solidFill>
+            <a:schemeClr val="phClr"/>
+          </a:solidFill>
+          <a:prstDash val="solid"/>
+        </a:ln>
+        <a:ln w="38100" cap="flat" cmpd="sng" algn="ctr">
+          <a:solidFill>
+            <a:schemeClr val="phClr"/>
+          </a:solidFill>
+          <a:prstDash val="solid"/>
+        </a:ln>
+      </a:lnStyleLst>
+      <a:effectStyleLst>
+        <a:effectStyle>
+          <a:effectLst>
+            <a:outerShdw blurRad="40000" dist="20000" dir="5400000" rotWithShape="0">
+              <a:srgbClr val="000000">
+                <a:alpha val="38000"/>
+              </a:srgbClr>
+            </a:outerShdw>
+          </a:effectLst>
+        </a:effectStyle>
+        <a:effectStyle>
+          <a:effectLst>
+            <a:outerShdw blurRad="40000" dist="23000" dir="5400000" rotWithShape="0">
+              <a:srgbClr val="000000">
+                <a:alpha val="35000"/>
+              </a:srgbClr>
+            </a:outerShdw>
+          </a:effectLst>
+        </a:effectStyle>
+        <a:effectStyle>
+          <a:effectLst>
+            <a:outerShdw blurRad="40000" dist="23000" dir="5400000" rotWithShape="0">
+              <a:srgbClr val="000000">
+                <a:alpha val="35000"/>
+              </a:srgbClr>
+            </a:outerShdw>
+          </a:effectLst>
+          <a:scene3d>
+            <a:camera prst="orthographicFront">
+              <a:rot lat="0" lon="0" rev="0"/>
+            </a:camera>
+            <a:lightRig rig="threePt" dir="t">
+              <a:rot lat="0" lon="0" rev="1200000"/>
+            </a:lightRig>
+          </a:scene3d>
+          <a:sp3d>
+            <a:bevelT w="63500" h="25400"/>
+          </a:sp3d>
+        </a:effectStyle>
+      </a:effectStyleLst>
+      <a:bgFillStyleLst>
+        <a:solidFill>
+          <a:schemeClr val="phClr"/>
+        </a:solidFill>
+        <a:gradFill rotWithShape="1">
+          <a:gsLst>
+            <a:gs pos="0">
+              <a:schemeClr val="phClr">
+                <a:tint val="40000"/>
+                <a:satMod val="350000"/>
+              </a:schemeClr>
+            </a:gs>
+            <a:gs pos="40000">
+              <a:schemeClr val="phClr">
+                <a:tint val="45000"/>
+                <a:shade val="99000"/>
+                <a:satMod val="350000"/>
+              </a:schemeClr>
+            </a:gs>
+            <a:gs pos="100000">
+              <a:schemeClr val="phClr">
+                <a:shade val="20000"/>
+                <a:satMod val="255000"/>
+              </a:schemeClr>
+            </a:gs>
+          </a:gsLst>
+          <a:path path="circle">
+            <a:fillToRect l="50000" t="-80000" r="50000" b="180000"/>
+          </a:path>
+        </a:gradFill>
+        <a:gradFill rotWithShape="1">
+          <a:gsLst>
+            <a:gs pos="0">
+              <a:schemeClr val="phClr">
+                <a:tint val="80000"/>
+                <a:satMod val="300000"/>
+              </a:schemeClr>
+            </a:gs>
+            <a:gs pos="100000">
+              <a:schemeClr val="phClr">
+                <a:shade val="30000"/>
+                <a:satMod val="200000"/>
+              </a:schemeClr>
+            </a:gs>
+          </a:gsLst>
+          <a:path path="circle">
+            <a:fillToRect l="50000" t="50000" r="50000" b="50000"/>
+          </a:path>
+        </a:gradFill>
+      </a:bgFillStyleLst>
+    </a:fmtScheme>
+  </a:themeElements>
+  <a:objectDefaults>
+    <a:spDef>
+      <a:spPr/>
+      <a:bodyPr/>
+      <a:lstStyle/>
+      <a:style>
+        <a:lnRef idx="1">
+          <a:schemeClr val="accent1"/>
+        </a:lnRef>
+        <a:fillRef idx="3">
+          <a:schemeClr val="accent1"/>
+        </a:fillRef>
+        <a:effectRef idx="2">
+          <a:schemeClr val="accent1"/>
+        </a:effectRef>
+        <a:fontRef idx="minor">
+          <a:schemeClr val="lt1"/>
+        </a:fontRef>
+      </a:style>
+    </a:spDef>
+    <a:lnDef>
+      <a:spPr/>
+      <a:bodyPr/>
+      <a:lstStyle/>
+      <a:style>
+        <a:lnRef idx="2">
+          <a:schemeClr val="accent1"/>
+        </a:lnRef>
+        <a:fillRef idx="0">
+          <a:schemeClr val="accent1"/>
+        </a:fillRef>
+        <a:effectRef idx="1">
+          <a:schemeClr val="accent1"/>
+        </a:effectRef>
+        <a:fontRef idx="minor">
+          <a:schemeClr val="tx1"/>
+        </a:fontRef>
+      </a:style>
+    </a:lnDef>
+  </a:objectDefaults>
+  <a:extraClrSchemeLst/>
+</a:theme>
 </file>
</xml_diff>

<commit_message>
chore(slides): update workflow presentation files for retreat slot 6
</commit_message>
<xml_diff>
--- a/docs/slides/fairst-workflow-slides-editable.pptx
+++ b/docs/slides/fairst-workflow-slides-editable.pptx
@@ -583,46 +583,23 @@
           <a:lstStyle/>
           <a:p>
             <a:r>
-              <a:t>The pipeline is strictly sequential. Schema.org JSON-LD from an RDI (Research Data Infrastructure) enters at the top, gets transformed by FAIRagro templates, and produces two outputs in order:</a:t>
+              <a:t>The pipeline is strictly sequential. Schema.org JSON-LD from an RDI enters at the top, gets transformed by FAIRagro templates, and produces two outputs in order: 1. Output A — ARC RO-Crate. 2. Output B — FAIRagro JSON, derived from Output A.</a:t>
             </a:r>
           </a:p>
           <a:p/>
           <a:p>
             <a:r>
-              <a:t>1. Output A — ARC RO-Crate. A JSON-LD document that follows the ARC specification.</a:t>
-            </a:r>
-          </a:p>
-          <a:p>
-            <a:r>
-              <a:t>2. Output B — FAIRagro JSON. Derived from Output A, not produced independently.</a:t>
-            </a:r>
-          </a:p>
-          <a:p/>
-          <a:p>
-            <a:r>
-              <a:t>Output B's dependency on Output A is the key architectural insight. If the ARC is incomplete, the FAIRagro extraction is incomplete too. There is no shortcut.</a:t>
-            </a:r>
-          </a:p>
-          <a:p/>
-          <a:p>
-            <a:r>
               <a:t>Two paths feed the ARC into Search Hub:</a:t>
             </a:r>
           </a:p>
           <a:p>
             <a:r>
-              <a:t>- Path 1 (direct harvest): GitLab DataHub stores the ARC; a harvester reads it and produces FAIRagro JSON.</a:t>
-            </a:r>
-          </a:p>
-          <a:p>
-            <a:r>
-              <a:t>- Path 2 (orchestrated): The FAIRagro Middleware API coordinates the full workflow, from harvest through conversion to ingestion.</a:t>
-            </a:r>
-          </a:p>
-          <a:p/>
-          <a:p>
-            <a:r>
-              <a:t>Both paths converge on the same FAIRagro schema.json consumed by Search Hub.</a:t>
+              <a:t>- Path 1 (direct harvest): GitLab DataHub stores the ARC; a harvester reads it.</a:t>
+            </a:r>
+          </a:p>
+          <a:p>
+            <a:r>
+              <a:t>- Path 2 (orchestrated): The FAIRagro Middleware API coordinates the full workflow.</a:t>
             </a:r>
           </a:p>
         </p:txBody>
@@ -692,31 +669,13 @@
           <a:lstStyle/>
           <a:p>
             <a:r>
-              <a:t>Three test files illustrate the relationship between ARC quality and extraction depth:</a:t>
+              <a:t>Three test files: Synthetic (wheat-full) → full extraction. Real — Small (dronflyover) → partial, mappable fields only. Real — Large (muenchenberg-lte) → basic harvest only.</a:t>
             </a:r>
           </a:p>
           <a:p/>
           <a:p>
             <a:r>
-              <a:t>Synthetic (schema-org-wheat-full.json): A manually crafted input designed to cover every FAIRagro-required field. The resulting ARC is fully compliant; extraction gets everything. This proves the pipeline works when the input follows the rules.</a:t>
-            </a:r>
-          </a:p>
-          <a:p/>
-          <a:p>
-            <a:r>
-              <a:t>Real — Small (arc-ro-crate-dronflyover.json, &lt;10 MB): An actual agronomic ARC from the UC13 drone flyover. It follows the ISA Investigation → Study → Assay hierarchy but uses non-standard property names and missing optional fields. Result: partial extraction. Only fields that map unambiguously to the FAIRagro schema come through.</a:t>
-            </a:r>
-          </a:p>
-          <a:p/>
-          <a:p>
-            <a:r>
-              <a:t>Real — Large (arc-ro-crate-muenchenberg-lte.json, &gt;100 MB): A long-term experiment ARC from Müncheberg with 27+ assays but a flatter structure. Many domain-specific fields don’t match any FAIRagro template key. Result: basic harvest only — title, description, identifier, creator.</a:t>
-            </a:r>
-          </a:p>
-          <a:p/>
-          <a:p>
-            <a:r>
-              <a:t>The pattern is clear: compliance determines extraction depth. If an ARC follows the FAIRagro specification, you get full extraction. If not, you get the intersection of what’s present and what’s mappable.</a:t>
+              <a:t>Compliance determines extraction depth. Well-structured ARCs enable full extraction.</a:t>
             </a:r>
           </a:p>
         </p:txBody>
@@ -786,35 +745,7 @@
           <a:lstStyle/>
           <a:p>
             <a:r>
-              <a:t>Two real ARCs, one problem: same domain concepts at different graph depths.</a:t>
-            </a:r>
-          </a:p>
-          <a:p/>
-          <a:p>
-            <a:r>
-              <a:t>Drone Flyover (UC13):</a:t>
-            </a:r>
-          </a:p>
-          <a:p>
-            <a:r>
-              <a:t>Following the ISA hierarchy: Investigation → Study → Assay. Two Agrischemas concepts live at very different traversal depths:</a:t>
-            </a:r>
-          </a:p>
-          <a:p/>
-          <a:p>
-            <a:r>
-              <a:t>- sensorType is 1 hop from Assay via measurementMethod → DefinedTerm.</a:t>
-            </a:r>
-          </a:p>
-          <a:p>
-            <a:r>
-              <a:t>- cropSpecies is 4 hops from Study via about → LabProcess → object → Sample → additionalProperty → PropertyValue.</a:t>
-            </a:r>
-          </a:p>
-          <a:p/>
-          <a:p>
-            <a:r>
-              <a:t>The sensorType path is short and direct. The cropSpecies path requires traversing five nodes with specific predicates at each step. The parser must know the exact path — any deviation and it loses the concept.</a:t>
+              <a:t>Drone Flyover (UC13): sensorType is 1 hop from Assay via measurementMethod → DefinedTerm. cropSpecies is 4 hops from Study via about → LabProcess → object → Sample → additionalProperty → PropertyValue.</a:t>
             </a:r>
           </a:p>
         </p:txBody>
@@ -884,18 +815,7 @@
           <a:lstStyle/>
           <a:p>
             <a:r>
-              <a:t>Müncheberg LTE:</a:t>
-            </a:r>
-          </a:p>
-          <a:p>
-            <a:r>
-              <a:t>A structurally different ARC. Investigation connects directly to 27+ Assays; a Study entity exists (studies/LTE-V140-Muencheberg/) but is NOT linked via the Investigation’s hasPart chain. Crop species surfaces via a shorter alternative path: Source → additionalProperty → CharacteristicValue (2 hops instead of 4). Müncheberg also has the same long LabProcess chain as the drone flyover (via Study.about → LabProcess → object → Source → additionalProperty), so both paths coexist. Sensor metadata is absent because this ARC is about crop phenology, not remote sensing.</a:t>
-            </a:r>
-          </a:p>
-          <a:p/>
-          <a:p>
-            <a:r>
-              <a:t>A generic parser cannot reliably extract crop species from both ARCs without knowing which structural pattern to apply. This variability is the core motivation for standardization.</a:t>
+              <a:t>Müncheberg LTE: Study disconnected from hasPart chain. Crop species via shorter path: Source → additionalProperty → CharacteristicValue (2 hops). 27+ assays, no sensor metadata (crop phenology, not remote sensing).</a:t>
             </a:r>
           </a:p>
         </p:txBody>
@@ -965,48 +885,13 @@
           <a:lstStyle/>
           <a:p>
             <a:r>
-              <a:t>After examining both ARCs, a required traversal path emerges for unambiguous crop extraction:</a:t>
+              <a:t>Required path for unambiguous crop extraction: Study → about → LabProcess → object → Sample/additionalType:Material → additionalProperty → PropertyValue/propertyID.</a:t>
             </a:r>
           </a:p>
           <a:p/>
           <a:p>
             <a:r>
-              <a:t>Study → about → LabProcess → object → Sample/additionalType:Material</a:t>
-            </a:r>
-          </a:p>
-          <a:p>
-            <a:r>
-              <a:t>  → additionalProperty → PropertyValue/propertyID</a:t>
-            </a:r>
-          </a:p>
-          <a:p/>
-          <a:p>
-            <a:r>
-              <a:t>The terminal node — PropertyValue with a propertyID — is critical. name: Organism and value: Solanum tuberosum are human-readable but machine-ambiguous. The propertyID linking to an ontology term (e.g., agrovoc:c_49904) makes it semantically precise and machine-resolvable.</a:t>
-            </a:r>
-          </a:p>
-          <a:p/>
-          <a:p>
-            <a:r>
-              <a:t>Two open questions remain:</a:t>
-            </a:r>
-          </a:p>
-          <a:p/>
-          <a:p>
-            <a:r>
-              <a:t>1. Structure specification. How do we formally specify a required graph traversal path so that tools can validate compliance automatically? A shape expression (ShEx) or SHACL shape? A simple property-path DSL in the pivot registry YAML?</a:t>
-            </a:r>
-          </a:p>
-          <a:p/>
-          <a:p>
-            <a:r>
-              <a:t>2. Ontology mapping standardization. propertyID values need a shared vocabulary of mappings so that every ARC uses the same ontology term for “crop species.” SSSOM (Simple Standard for Sharing Ontological Mappings) is a candidate — but it needs community adoption.</a:t>
-            </a:r>
-          </a:p>
-          <a:p/>
-          <a:p>
-            <a:r>
-              <a:t>These are not FAIRweaver problems. They are community-level standardization problems that FAIRweaver exposes and quantifies.</a:t>
+              <a:t>Open questions: (1) How to formally specify traversal paths? (2) How to standardize ontology term mappings via SSSOM?</a:t>
             </a:r>
           </a:p>
         </p:txBody>

</xml_diff>